<commit_message>
dittvin T3: horizontal box selector + collapsible taste accordion with per-wine profile + bottle counts; refresh PPTX
</commit_message>
<xml_diff>
--- a/dittvin-cro-audit/dittvin-ecomhouse-pitch.pptx
+++ b/dittvin-cro-audit/dittvin-ecomhouse-pitch.pptx
@@ -37905,8 +37905,8 @@
         </p:blipFill>
         <p:spPr>
           <a:xfrm>
-            <a:off x="7824209" y="868680"/>
-            <a:ext cx="2029676" cy="4892040"/>
+            <a:off x="7955762" y="868680"/>
+            <a:ext cx="1766570" cy="4892040"/>
           </a:xfrm>
           <a:prstGeom prst="rect">
             <a:avLst/>

</xml_diff>

<commit_message>
dittvin T3: compact per-wine taste pips (space fix); refresh PPTX thumbnail
</commit_message>
<xml_diff>
--- a/dittvin-cro-audit/dittvin-ecomhouse-pitch.pptx
+++ b/dittvin-cro-audit/dittvin-ecomhouse-pitch.pptx
@@ -37905,8 +37905,8 @@
         </p:blipFill>
         <p:spPr>
           <a:xfrm>
-            <a:off x="7955762" y="868680"/>
-            <a:ext cx="1766570" cy="4892040"/>
+            <a:off x="7941404" y="868680"/>
+            <a:ext cx="1795286" cy="4892040"/>
           </a:xfrm>
           <a:prstGeom prst="rect">
             <a:avLst/>

</xml_diff>